<commit_message>
Harden operations and reproducibility
</commit_message>
<xml_diff>
--- a/presentation/Africa_Pulse_Live_Platform_Briefing.pptx
+++ b/presentation/Africa_Pulse_Live_Platform_Briefing.pptx
@@ -4232,7 +4232,7 @@
               </a:defRPr>
             </a:pPr>
             <a:r>
-              <a:t>9</a:t>
+              <a:t>16</a:t>
             </a:r>
           </a:p>
         </p:txBody>
@@ -4271,7 +4271,7 @@
               </a:defRPr>
             </a:pPr>
             <a:r>
-              <a:t>7 completed; failures retained as evidence</a:t>
+              <a:t>12 completed; failures retained as evidence</a:t>
             </a:r>
           </a:p>
         </p:txBody>
@@ -4781,7 +4781,7 @@
               </a:defRPr>
             </a:pPr>
             <a:r>
-              <a:t>Median congestion | 100% validated sample coverage</a:t>
+              <a:t>Median congestion | 50% validated sample coverage</a:t>
             </a:r>
           </a:p>
         </p:txBody>
@@ -4949,7 +4949,7 @@
               </a:defRPr>
             </a:pPr>
             <a:r>
-              <a:t>39.5%</a:t>
+              <a:t>32.0%</a:t>
             </a:r>
           </a:p>
         </p:txBody>
@@ -4988,7 +4988,7 @@
               </a:defRPr>
             </a:pPr>
             <a:r>
-              <a:t>Median congestion | 100% validated sample coverage</a:t>
+              <a:t>Median congestion | 50% validated sample coverage</a:t>
             </a:r>
           </a:p>
         </p:txBody>
@@ -5156,7 +5156,7 @@
               </a:defRPr>
             </a:pPr>
             <a:r>
-              <a:t>15.7%</a:t>
+              <a:t>27.6%</a:t>
             </a:r>
           </a:p>
         </p:txBody>
@@ -5195,7 +5195,7 @@
               </a:defRPr>
             </a:pPr>
             <a:r>
-              <a:t>Median congestion | 100% validated sample coverage</a:t>
+              <a:t>Median congestion | 50% validated sample coverage</a:t>
             </a:r>
           </a:p>
         </p:txBody>

</xml_diff>

<commit_message>
Add presentation defense guide and live deck status
</commit_message>
<xml_diff>
--- a/presentation/Africa_Pulse_Live_Platform_Briefing.pptx
+++ b/presentation/Africa_Pulse_Live_Platform_Briefing.pptx
@@ -3986,7 +3986,7 @@
               </a:defRPr>
             </a:pPr>
             <a:r>
-              <a:t>Live traffic facts</a:t>
+              <a:t>Traffic facts stored</a:t>
             </a:r>
           </a:p>
         </p:txBody>
@@ -4025,7 +4025,7 @@
               </a:defRPr>
             </a:pPr>
             <a:r>
-              <a:t>15</a:t>
+              <a:t>30</a:t>
             </a:r>
           </a:p>
         </p:txBody>
@@ -4064,7 +4064,7 @@
               </a:defRPr>
             </a:pPr>
             <a:r>
-              <a:t>Five validated road samples per city</a:t>
+              <a:t>Five configured road samples per city</a:t>
             </a:r>
           </a:p>
         </p:txBody>
@@ -6758,7 +6758,7 @@
               </a:defRPr>
             </a:pPr>
             <a:r>
-              <a:t>Overpass incident</a:t>
+              <a:t>Latest commercial run</a:t>
             </a:r>
           </a:p>
         </p:txBody>
@@ -6797,7 +6797,7 @@
               </a:defRPr>
             </a:pPr>
             <a:r>
-              <a:t>HTTP 406</a:t>
+              <a:t>FAILED</a:t>
             </a:r>
           </a:p>
         </p:txBody>
@@ -6836,7 +6836,7 @@
               </a:defRPr>
             </a:pPr>
             <a:r>
-              <a:t>Initial commercial request failed and was logged</a:t>
+              <a:t>Rate-limited source failure is retained and visible</a:t>
             </a:r>
           </a:p>
         </p:txBody>
@@ -6965,7 +6965,7 @@
               </a:defRPr>
             </a:pPr>
             <a:r>
-              <a:t>Recovery</a:t>
+              <a:t>Recovery design</a:t>
             </a:r>
           </a:p>
         </p:txBody>
@@ -7004,7 +7004,7 @@
               </a:defRPr>
             </a:pPr>
             <a:r>
-              <a:t>POST retry</a:t>
+              <a:t>Buffered write</a:t>
             </a:r>
           </a:p>
         </p:txBody>
@@ -7043,7 +7043,7 @@
               </a:defRPr>
             </a:pPr>
             <a:r>
-              <a:t>Completed after connector adjustment</a:t>
+              <a:t>Future snapshots publish only after all cities are acquired</a:t>
             </a:r>
           </a:p>
         </p:txBody>
@@ -7328,7 +7328,7 @@
               </a:defRPr>
             </a:pPr>
             <a:r>
-              <a:t>An independent engineer can see what failed, inspect the source evidence, correct the connector, rerun the workflow, and prove that recovery did not duplicate records.</a:t>
+              <a:t>An independent engineer can see what failed, inspect the source evidence, wait for the provider limit to clear, rerun the workflow, and prove that recovery did not duplicate records.</a:t>
             </a:r>
           </a:p>
         </p:txBody>

</xml_diff>

<commit_message>
Add business question readiness gates
</commit_message>
<xml_diff>
--- a/presentation/Africa_Pulse_Live_Platform_Briefing.pptx
+++ b/presentation/Africa_Pulse_Live_Platform_Briefing.pptx
@@ -12,6 +12,7 @@
     <p:sldId id="260" r:id="rId11"/>
     <p:sldId id="261" r:id="rId12"/>
     <p:sldId id="262" r:id="rId13"/>
+    <p:sldId id="263" r:id="rId14"/>
   </p:sldIdLst>
   <p:sldSz cx="12191695" cy="6858000" type="screen4x3"/>
   <p:notesSz cx="6858000" cy="9144000"/>
@@ -8356,7 +8357,7 @@
               </a:defRPr>
             </a:pPr>
             <a:r>
-              <a:t>The next decision is operational maturity, not new features</a:t>
+              <a:t>Every required question has an evidence gate</a:t>
             </a:r>
           </a:p>
         </p:txBody>
@@ -8395,7 +8396,7 @@
               </a:defRPr>
             </a:pPr>
             <a:r>
-              <a:t>The platform is demonstrable today; scheduled collection will turn the initial vertical slice into a historical decision asset.</a:t>
+              <a:t>The platform reports whether a conclusion is supported, partial, or not yet answerable.</a:t>
             </a:r>
           </a:p>
         </p:txBody>
@@ -8478,6 +8479,1379 @@
             </a:pPr>
             <a:r>
               <a:t>07</a:t>
+            </a:r>
+          </a:p>
+        </p:txBody>
+      </p:sp>
+      <p:sp>
+        <p:nvSpPr>
+          <p:cNvPr id="7" name="Rounded Rectangle 6"/>
+          <p:cNvSpPr/>
+          <p:nvPr/>
+        </p:nvSpPr>
+        <p:spPr>
+          <a:xfrm>
+            <a:off x="502920" y="1755648"/>
+            <a:ext cx="5074920" cy="896112"/>
+          </a:xfrm>
+          <a:prstGeom prst="roundRect">
+            <a:avLst>
+              <a:gd name="adj" fmla="val 6000"/>
+            </a:avLst>
+          </a:prstGeom>
+          <a:solidFill>
+            <a:srgbClr val="F8FBFD"/>
+          </a:solidFill>
+          <a:ln>
+            <a:solidFill>
+              <a:srgbClr val="D9E2EC"/>
+            </a:solidFill>
+          </a:ln>
+        </p:spPr>
+        <p:style>
+          <a:lnRef idx="1">
+            <a:schemeClr val="accent1"/>
+          </a:lnRef>
+          <a:fillRef idx="3">
+            <a:schemeClr val="accent1"/>
+          </a:fillRef>
+          <a:effectRef idx="2">
+            <a:schemeClr val="accent1"/>
+          </a:effectRef>
+          <a:fontRef idx="minor">
+            <a:schemeClr val="lt1"/>
+          </a:fontRef>
+        </p:style>
+        <p:txBody>
+          <a:bodyPr rtlCol="0" anchor="ctr"/>
+          <a:lstStyle/>
+          <a:p>
+            <a:pPr algn="ctr"/>
+          </a:p>
+        </p:txBody>
+      </p:sp>
+      <p:sp>
+        <p:nvSpPr>
+          <p:cNvPr id="8" name="TextBox 7"/>
+          <p:cNvSpPr txBox="1"/>
+          <p:nvPr/>
+        </p:nvSpPr>
+        <p:spPr>
+          <a:xfrm>
+            <a:off x="685800" y="1911095"/>
+            <a:ext cx="3383280" cy="164592"/>
+          </a:xfrm>
+          <a:prstGeom prst="rect">
+            <a:avLst/>
+          </a:prstGeom>
+          <a:noFill/>
+        </p:spPr>
+        <p:txBody>
+          <a:bodyPr wrap="square">
+            <a:spAutoFit/>
+          </a:bodyPr>
+          <a:lstStyle/>
+          <a:p>
+            <a:pPr algn="l">
+              <a:spcAft>
+                <a:spcPts val="0"/>
+              </a:spcAft>
+              <a:defRPr sz="1100" b="1">
+                <a:solidFill>
+                  <a:srgbClr val="102A43"/>
+                </a:solidFill>
+                <a:latin typeface="Aptos"/>
+              </a:defRPr>
+            </a:pPr>
+            <a:r>
+              <a:t>Mobility And Commercial Activity</a:t>
+            </a:r>
+          </a:p>
+        </p:txBody>
+      </p:sp>
+      <p:sp>
+        <p:nvSpPr>
+          <p:cNvPr id="9" name="TextBox 8"/>
+          <p:cNvSpPr txBox="1"/>
+          <p:nvPr/>
+        </p:nvSpPr>
+        <p:spPr>
+          <a:xfrm>
+            <a:off x="4142232" y="1911095"/>
+            <a:ext cx="1188720" cy="164592"/>
+          </a:xfrm>
+          <a:prstGeom prst="rect">
+            <a:avLst/>
+          </a:prstGeom>
+          <a:noFill/>
+        </p:spPr>
+        <p:txBody>
+          <a:bodyPr wrap="square">
+            <a:spAutoFit/>
+          </a:bodyPr>
+          <a:lstStyle/>
+          <a:p>
+            <a:pPr algn="r">
+              <a:spcAft>
+                <a:spcPts val="0"/>
+              </a:spcAft>
+              <a:defRPr sz="1000" b="1">
+                <a:solidFill>
+                  <a:srgbClr val="B45309"/>
+                </a:solidFill>
+                <a:latin typeface="Aptos"/>
+              </a:defRPr>
+            </a:pPr>
+            <a:r>
+              <a:t>PARTIAL</a:t>
+            </a:r>
+          </a:p>
+        </p:txBody>
+      </p:sp>
+      <p:sp>
+        <p:nvSpPr>
+          <p:cNvPr id="10" name="TextBox 9"/>
+          <p:cNvSpPr txBox="1"/>
+          <p:nvPr/>
+        </p:nvSpPr>
+        <p:spPr>
+          <a:xfrm>
+            <a:off x="685800" y="2185415"/>
+            <a:ext cx="4617720" cy="274320"/>
+          </a:xfrm>
+          <a:prstGeom prst="rect">
+            <a:avLst/>
+          </a:prstGeom>
+          <a:noFill/>
+        </p:spPr>
+        <p:txBody>
+          <a:bodyPr wrap="square">
+            <a:spAutoFit/>
+          </a:bodyPr>
+          <a:lstStyle/>
+          <a:p>
+            <a:pPr algn="l">
+              <a:spcAft>
+                <a:spcPts val="0"/>
+              </a:spcAft>
+              <a:defRPr sz="800" b="0">
+                <a:solidFill>
+                  <a:srgbClr val="486581"/>
+                </a:solidFill>
+                <a:latin typeface="Aptos"/>
+              </a:defRPr>
+            </a:pPr>
+            <a:r>
+              <a:t>Mobility is a sampled congestion proxy; commercial counts are not density without an approved boundary and population denominator.</a:t>
+            </a:r>
+          </a:p>
+        </p:txBody>
+      </p:sp>
+      <p:sp>
+        <p:nvSpPr>
+          <p:cNvPr id="11" name="Rounded Rectangle 10"/>
+          <p:cNvSpPr/>
+          <p:nvPr/>
+        </p:nvSpPr>
+        <p:spPr>
+          <a:xfrm>
+            <a:off x="6126480" y="1755648"/>
+            <a:ext cx="5074920" cy="896112"/>
+          </a:xfrm>
+          <a:prstGeom prst="roundRect">
+            <a:avLst>
+              <a:gd name="adj" fmla="val 6000"/>
+            </a:avLst>
+          </a:prstGeom>
+          <a:solidFill>
+            <a:srgbClr val="F8FBFD"/>
+          </a:solidFill>
+          <a:ln>
+            <a:solidFill>
+              <a:srgbClr val="D9E2EC"/>
+            </a:solidFill>
+          </a:ln>
+        </p:spPr>
+        <p:style>
+          <a:lnRef idx="1">
+            <a:schemeClr val="accent1"/>
+          </a:lnRef>
+          <a:fillRef idx="3">
+            <a:schemeClr val="accent1"/>
+          </a:fillRef>
+          <a:effectRef idx="2">
+            <a:schemeClr val="accent1"/>
+          </a:effectRef>
+          <a:fontRef idx="minor">
+            <a:schemeClr val="lt1"/>
+          </a:fontRef>
+        </p:style>
+        <p:txBody>
+          <a:bodyPr rtlCol="0" anchor="ctr"/>
+          <a:lstStyle/>
+          <a:p>
+            <a:pPr algn="ctr"/>
+          </a:p>
+        </p:txBody>
+      </p:sp>
+      <p:sp>
+        <p:nvSpPr>
+          <p:cNvPr id="12" name="TextBox 11"/>
+          <p:cNvSpPr txBox="1"/>
+          <p:nvPr/>
+        </p:nvSpPr>
+        <p:spPr>
+          <a:xfrm>
+            <a:off x="6309360" y="1911095"/>
+            <a:ext cx="3383280" cy="164592"/>
+          </a:xfrm>
+          <a:prstGeom prst="rect">
+            <a:avLst/>
+          </a:prstGeom>
+          <a:noFill/>
+        </p:spPr>
+        <p:txBody>
+          <a:bodyPr wrap="square">
+            <a:spAutoFit/>
+          </a:bodyPr>
+          <a:lstStyle/>
+          <a:p>
+            <a:pPr algn="l">
+              <a:spcAft>
+                <a:spcPts val="0"/>
+              </a:spcAft>
+              <a:defRPr sz="1100" b="1">
+                <a:solidFill>
+                  <a:srgbClr val="102A43"/>
+                </a:solidFill>
+                <a:latin typeface="Aptos"/>
+              </a:defRPr>
+            </a:pPr>
+            <a:r>
+              <a:t>Weather And Mobility Relationship</a:t>
+            </a:r>
+          </a:p>
+        </p:txBody>
+      </p:sp>
+      <p:sp>
+        <p:nvSpPr>
+          <p:cNvPr id="13" name="TextBox 12"/>
+          <p:cNvSpPr txBox="1"/>
+          <p:nvPr/>
+        </p:nvSpPr>
+        <p:spPr>
+          <a:xfrm>
+            <a:off x="9765792" y="1911095"/>
+            <a:ext cx="1188720" cy="164592"/>
+          </a:xfrm>
+          <a:prstGeom prst="rect">
+            <a:avLst/>
+          </a:prstGeom>
+          <a:noFill/>
+        </p:spPr>
+        <p:txBody>
+          <a:bodyPr wrap="square">
+            <a:spAutoFit/>
+          </a:bodyPr>
+          <a:lstStyle/>
+          <a:p>
+            <a:pPr algn="r">
+              <a:spcAft>
+                <a:spcPts val="0"/>
+              </a:spcAft>
+              <a:defRPr sz="1000" b="1">
+                <a:solidFill>
+                  <a:srgbClr val="B42318"/>
+                </a:solidFill>
+                <a:latin typeface="Aptos"/>
+              </a:defRPr>
+            </a:pPr>
+            <a:r>
+              <a:t>NOT READY</a:t>
+            </a:r>
+          </a:p>
+        </p:txBody>
+      </p:sp>
+      <p:sp>
+        <p:nvSpPr>
+          <p:cNvPr id="14" name="TextBox 13"/>
+          <p:cNvSpPr txBox="1"/>
+          <p:nvPr/>
+        </p:nvSpPr>
+        <p:spPr>
+          <a:xfrm>
+            <a:off x="6309360" y="2185415"/>
+            <a:ext cx="4617720" cy="274320"/>
+          </a:xfrm>
+          <a:prstGeom prst="rect">
+            <a:avLst/>
+          </a:prstGeom>
+          <a:noFill/>
+        </p:spPr>
+        <p:txBody>
+          <a:bodyPr wrap="square">
+            <a:spAutoFit/>
+          </a:bodyPr>
+          <a:lstStyle/>
+          <a:p>
+            <a:pPr algn="l">
+              <a:spcAft>
+                <a:spcPts val="0"/>
+              </a:spcAft>
+              <a:defRPr sz="800" b="0">
+                <a:solidFill>
+                  <a:srgbClr val="486581"/>
+                </a:solidFill>
+                <a:latin typeface="Aptos"/>
+              </a:defRPr>
+            </a:pPr>
+            <a:r>
+              <a:t>Requires 28 shared local days; currently mobility_days=2, climate_days=2.</a:t>
+            </a:r>
+          </a:p>
+        </p:txBody>
+      </p:sp>
+      <p:sp>
+        <p:nvSpPr>
+          <p:cNvPr id="15" name="Rounded Rectangle 14"/>
+          <p:cNvSpPr/>
+          <p:nvPr/>
+        </p:nvSpPr>
+        <p:spPr>
+          <a:xfrm>
+            <a:off x="502920" y="2916936"/>
+            <a:ext cx="5074920" cy="896112"/>
+          </a:xfrm>
+          <a:prstGeom prst="roundRect">
+            <a:avLst>
+              <a:gd name="adj" fmla="val 6000"/>
+            </a:avLst>
+          </a:prstGeom>
+          <a:solidFill>
+            <a:srgbClr val="F8FBFD"/>
+          </a:solidFill>
+          <a:ln>
+            <a:solidFill>
+              <a:srgbClr val="D9E2EC"/>
+            </a:solidFill>
+          </a:ln>
+        </p:spPr>
+        <p:style>
+          <a:lnRef idx="1">
+            <a:schemeClr val="accent1"/>
+          </a:lnRef>
+          <a:fillRef idx="3">
+            <a:schemeClr val="accent1"/>
+          </a:fillRef>
+          <a:effectRef idx="2">
+            <a:schemeClr val="accent1"/>
+          </a:effectRef>
+          <a:fontRef idx="minor">
+            <a:schemeClr val="lt1"/>
+          </a:fontRef>
+        </p:style>
+        <p:txBody>
+          <a:bodyPr rtlCol="0" anchor="ctr"/>
+          <a:lstStyle/>
+          <a:p>
+            <a:pPr algn="ctr"/>
+          </a:p>
+        </p:txBody>
+      </p:sp>
+      <p:sp>
+        <p:nvSpPr>
+          <p:cNvPr id="16" name="TextBox 15"/>
+          <p:cNvSpPr txBox="1"/>
+          <p:nvPr/>
+        </p:nvSpPr>
+        <p:spPr>
+          <a:xfrm>
+            <a:off x="685800" y="3072384"/>
+            <a:ext cx="3383280" cy="164592"/>
+          </a:xfrm>
+          <a:prstGeom prst="rect">
+            <a:avLst/>
+          </a:prstGeom>
+          <a:noFill/>
+        </p:spPr>
+        <p:txBody>
+          <a:bodyPr wrap="square">
+            <a:spAutoFit/>
+          </a:bodyPr>
+          <a:lstStyle/>
+          <a:p>
+            <a:pPr algn="l">
+              <a:spcAft>
+                <a:spcPts val="0"/>
+              </a:spcAft>
+              <a:defRPr sz="1100" b="1">
+                <a:solidFill>
+                  <a:srgbClr val="102A43"/>
+                </a:solidFill>
+                <a:latin typeface="Aptos"/>
+              </a:defRPr>
+            </a:pPr>
+            <a:r>
+              <a:t>Environmental Pressure</a:t>
+            </a:r>
+          </a:p>
+        </p:txBody>
+      </p:sp>
+      <p:sp>
+        <p:nvSpPr>
+          <p:cNvPr id="17" name="TextBox 16"/>
+          <p:cNvSpPr txBox="1"/>
+          <p:nvPr/>
+        </p:nvSpPr>
+        <p:spPr>
+          <a:xfrm>
+            <a:off x="4142232" y="3072384"/>
+            <a:ext cx="1188720" cy="164592"/>
+          </a:xfrm>
+          <a:prstGeom prst="rect">
+            <a:avLst/>
+          </a:prstGeom>
+          <a:noFill/>
+        </p:spPr>
+        <p:txBody>
+          <a:bodyPr wrap="square">
+            <a:spAutoFit/>
+          </a:bodyPr>
+          <a:lstStyle/>
+          <a:p>
+            <a:pPr algn="r">
+              <a:spcAft>
+                <a:spcPts val="0"/>
+              </a:spcAft>
+              <a:defRPr sz="1000" b="1">
+                <a:solidFill>
+                  <a:srgbClr val="B45309"/>
+                </a:solidFill>
+                <a:latin typeface="Aptos"/>
+              </a:defRPr>
+            </a:pPr>
+            <a:r>
+              <a:t>PARTIAL</a:t>
+            </a:r>
+          </a:p>
+        </p:txBody>
+      </p:sp>
+      <p:sp>
+        <p:nvSpPr>
+          <p:cNvPr id="18" name="TextBox 17"/>
+          <p:cNvSpPr txBox="1"/>
+          <p:nvPr/>
+        </p:nvSpPr>
+        <p:spPr>
+          <a:xfrm>
+            <a:off x="685800" y="3346704"/>
+            <a:ext cx="4617720" cy="274320"/>
+          </a:xfrm>
+          <a:prstGeom prst="rect">
+            <a:avLst/>
+          </a:prstGeom>
+          <a:noFill/>
+        </p:spPr>
+        <p:txBody>
+          <a:bodyPr wrap="square">
+            <a:spAutoFit/>
+          </a:bodyPr>
+          <a:lstStyle/>
+          <a:p>
+            <a:pPr algn="l">
+              <a:spcAft>
+                <a:spcPts val="0"/>
+              </a:spcAft>
+              <a:defRPr sz="800" b="0">
+                <a:solidFill>
+                  <a:srgbClr val="486581"/>
+                </a:solidFill>
+                <a:latin typeface="Aptos"/>
+              </a:defRPr>
+            </a:pPr>
+            <a:r>
+              <a:t>Available as modelled PM2.5, PM10, and NO2 at each configured reference coordinate; not a ground-station city-wide measure.</a:t>
+            </a:r>
+          </a:p>
+        </p:txBody>
+      </p:sp>
+      <p:sp>
+        <p:nvSpPr>
+          <p:cNvPr id="19" name="Rounded Rectangle 18"/>
+          <p:cNvSpPr/>
+          <p:nvPr/>
+        </p:nvSpPr>
+        <p:spPr>
+          <a:xfrm>
+            <a:off x="6126480" y="2916936"/>
+            <a:ext cx="5074920" cy="896112"/>
+          </a:xfrm>
+          <a:prstGeom prst="roundRect">
+            <a:avLst>
+              <a:gd name="adj" fmla="val 6000"/>
+            </a:avLst>
+          </a:prstGeom>
+          <a:solidFill>
+            <a:srgbClr val="F8FBFD"/>
+          </a:solidFill>
+          <a:ln>
+            <a:solidFill>
+              <a:srgbClr val="D9E2EC"/>
+            </a:solidFill>
+          </a:ln>
+        </p:spPr>
+        <p:style>
+          <a:lnRef idx="1">
+            <a:schemeClr val="accent1"/>
+          </a:lnRef>
+          <a:fillRef idx="3">
+            <a:schemeClr val="accent1"/>
+          </a:fillRef>
+          <a:effectRef idx="2">
+            <a:schemeClr val="accent1"/>
+          </a:effectRef>
+          <a:fontRef idx="minor">
+            <a:schemeClr val="lt1"/>
+          </a:fontRef>
+        </p:style>
+        <p:txBody>
+          <a:bodyPr rtlCol="0" anchor="ctr"/>
+          <a:lstStyle/>
+          <a:p>
+            <a:pPr algn="ctr"/>
+          </a:p>
+        </p:txBody>
+      </p:sp>
+      <p:sp>
+        <p:nvSpPr>
+          <p:cNvPr id="20" name="TextBox 19"/>
+          <p:cNvSpPr txBox="1"/>
+          <p:nvPr/>
+        </p:nvSpPr>
+        <p:spPr>
+          <a:xfrm>
+            <a:off x="6309360" y="3072384"/>
+            <a:ext cx="3383280" cy="164592"/>
+          </a:xfrm>
+          <a:prstGeom prst="rect">
+            <a:avLst/>
+          </a:prstGeom>
+          <a:noFill/>
+        </p:spPr>
+        <p:txBody>
+          <a:bodyPr wrap="square">
+            <a:spAutoFit/>
+          </a:bodyPr>
+          <a:lstStyle/>
+          <a:p>
+            <a:pPr algn="l">
+              <a:spcAft>
+                <a:spcPts val="0"/>
+              </a:spcAft>
+              <a:defRPr sz="1100" b="1">
+                <a:solidFill>
+                  <a:srgbClr val="102A43"/>
+                </a:solidFill>
+                <a:latin typeface="Aptos"/>
+              </a:defRPr>
+            </a:pPr>
+            <a:r>
+              <a:t>Currency And Fuel Transport Economics</a:t>
+            </a:r>
+          </a:p>
+        </p:txBody>
+      </p:sp>
+      <p:sp>
+        <p:nvSpPr>
+          <p:cNvPr id="21" name="TextBox 20"/>
+          <p:cNvSpPr txBox="1"/>
+          <p:nvPr/>
+        </p:nvSpPr>
+        <p:spPr>
+          <a:xfrm>
+            <a:off x="9765792" y="3072384"/>
+            <a:ext cx="1188720" cy="164592"/>
+          </a:xfrm>
+          <a:prstGeom prst="rect">
+            <a:avLst/>
+          </a:prstGeom>
+          <a:noFill/>
+        </p:spPr>
+        <p:txBody>
+          <a:bodyPr wrap="square">
+            <a:spAutoFit/>
+          </a:bodyPr>
+          <a:lstStyle/>
+          <a:p>
+            <a:pPr algn="r">
+              <a:spcAft>
+                <a:spcPts val="0"/>
+              </a:spcAft>
+              <a:defRPr sz="1000" b="1">
+                <a:solidFill>
+                  <a:srgbClr val="B42318"/>
+                </a:solidFill>
+                <a:latin typeface="Aptos"/>
+              </a:defRPr>
+            </a:pPr>
+            <a:r>
+              <a:t>NOT READY</a:t>
+            </a:r>
+          </a:p>
+        </p:txBody>
+      </p:sp>
+      <p:sp>
+        <p:nvSpPr>
+          <p:cNvPr id="22" name="TextBox 21"/>
+          <p:cNvSpPr txBox="1"/>
+          <p:nvPr/>
+        </p:nvSpPr>
+        <p:spPr>
+          <a:xfrm>
+            <a:off x="6309360" y="3346704"/>
+            <a:ext cx="4617720" cy="274320"/>
+          </a:xfrm>
+          <a:prstGeom prst="rect">
+            <a:avLst/>
+          </a:prstGeom>
+          <a:noFill/>
+        </p:spPr>
+        <p:txBody>
+          <a:bodyPr wrap="square">
+            <a:spAutoFit/>
+          </a:bodyPr>
+          <a:lstStyle/>
+          <a:p>
+            <a:pPr algn="l">
+              <a:spcAft>
+                <a:spcPts val="0"/>
+              </a:spcAft>
+              <a:defRPr sz="800" b="0">
+                <a:solidFill>
+                  <a:srgbClr val="486581"/>
+                </a:solidFill>
+                <a:latin typeface="Aptos"/>
+              </a:defRPr>
+            </a:pPr>
+            <a:r>
+              <a:t>FX exists, but no permitted fuel-market source has been integrated. Add a documented official or licensed fuel-price source before analysis.</a:t>
+            </a:r>
+          </a:p>
+        </p:txBody>
+      </p:sp>
+      <p:sp>
+        <p:nvSpPr>
+          <p:cNvPr id="23" name="Rounded Rectangle 22"/>
+          <p:cNvSpPr/>
+          <p:nvPr/>
+        </p:nvSpPr>
+        <p:spPr>
+          <a:xfrm>
+            <a:off x="502920" y="4078224"/>
+            <a:ext cx="5074920" cy="896112"/>
+          </a:xfrm>
+          <a:prstGeom prst="roundRect">
+            <a:avLst>
+              <a:gd name="adj" fmla="val 6000"/>
+            </a:avLst>
+          </a:prstGeom>
+          <a:solidFill>
+            <a:srgbClr val="F8FBFD"/>
+          </a:solidFill>
+          <a:ln>
+            <a:solidFill>
+              <a:srgbClr val="D9E2EC"/>
+            </a:solidFill>
+          </a:ln>
+        </p:spPr>
+        <p:style>
+          <a:lnRef idx="1">
+            <a:schemeClr val="accent1"/>
+          </a:lnRef>
+          <a:fillRef idx="3">
+            <a:schemeClr val="accent1"/>
+          </a:fillRef>
+          <a:effectRef idx="2">
+            <a:schemeClr val="accent1"/>
+          </a:effectRef>
+          <a:fontRef idx="minor">
+            <a:schemeClr val="lt1"/>
+          </a:fontRef>
+        </p:style>
+        <p:txBody>
+          <a:bodyPr rtlCol="0" anchor="ctr"/>
+          <a:lstStyle/>
+          <a:p>
+            <a:pPr algn="ctr"/>
+          </a:p>
+        </p:txBody>
+      </p:sp>
+      <p:sp>
+        <p:nvSpPr>
+          <p:cNvPr id="24" name="TextBox 23"/>
+          <p:cNvSpPr txBox="1"/>
+          <p:nvPr/>
+        </p:nvSpPr>
+        <p:spPr>
+          <a:xfrm>
+            <a:off x="685800" y="4233672"/>
+            <a:ext cx="3383280" cy="164592"/>
+          </a:xfrm>
+          <a:prstGeom prst="rect">
+            <a:avLst/>
+          </a:prstGeom>
+          <a:noFill/>
+        </p:spPr>
+        <p:txBody>
+          <a:bodyPr wrap="square">
+            <a:spAutoFit/>
+          </a:bodyPr>
+          <a:lstStyle/>
+          <a:p>
+            <a:pPr algn="l">
+              <a:spcAft>
+                <a:spcPts val="0"/>
+              </a:spcAft>
+              <a:defRPr sz="1100" b="1">
+                <a:solidFill>
+                  <a:srgbClr val="102A43"/>
+                </a:solidFill>
+                <a:latin typeface="Aptos"/>
+              </a:defRPr>
+            </a:pPr>
+            <a:r>
+              <a:t>Commercial Services Relative To Population</a:t>
+            </a:r>
+          </a:p>
+        </p:txBody>
+      </p:sp>
+      <p:sp>
+        <p:nvSpPr>
+          <p:cNvPr id="25" name="TextBox 24"/>
+          <p:cNvSpPr txBox="1"/>
+          <p:nvPr/>
+        </p:nvSpPr>
+        <p:spPr>
+          <a:xfrm>
+            <a:off x="4142232" y="4233672"/>
+            <a:ext cx="1188720" cy="164592"/>
+          </a:xfrm>
+          <a:prstGeom prst="rect">
+            <a:avLst/>
+          </a:prstGeom>
+          <a:noFill/>
+        </p:spPr>
+        <p:txBody>
+          <a:bodyPr wrap="square">
+            <a:spAutoFit/>
+          </a:bodyPr>
+          <a:lstStyle/>
+          <a:p>
+            <a:pPr algn="r">
+              <a:spcAft>
+                <a:spcPts val="0"/>
+              </a:spcAft>
+              <a:defRPr sz="1000" b="1">
+                <a:solidFill>
+                  <a:srgbClr val="B42318"/>
+                </a:solidFill>
+                <a:latin typeface="Aptos"/>
+              </a:defRPr>
+            </a:pPr>
+            <a:r>
+              <a:t>NOT READY</a:t>
+            </a:r>
+          </a:p>
+        </p:txBody>
+      </p:sp>
+      <p:sp>
+        <p:nvSpPr>
+          <p:cNvPr id="26" name="TextBox 25"/>
+          <p:cNvSpPr txBox="1"/>
+          <p:nvPr/>
+        </p:nvSpPr>
+        <p:spPr>
+          <a:xfrm>
+            <a:off x="685800" y="4507992"/>
+            <a:ext cx="4617720" cy="274320"/>
+          </a:xfrm>
+          <a:prstGeom prst="rect">
+            <a:avLst/>
+          </a:prstGeom>
+          <a:noFill/>
+        </p:spPr>
+        <p:txBody>
+          <a:bodyPr wrap="square">
+            <a:spAutoFit/>
+          </a:bodyPr>
+          <a:lstStyle/>
+          <a:p>
+            <a:pPr algn="l">
+              <a:spcAft>
+                <a:spcPts val="0"/>
+              </a:spcAft>
+              <a:defRPr sz="800" b="0">
+                <a:solidFill>
+                  <a:srgbClr val="486581"/>
+                </a:solidFill>
+                <a:latin typeface="Aptos"/>
+              </a:defRPr>
+            </a:pPr>
+            <a:r>
+              <a:t>Requires an approved municipal boundary, a population denominator with reference date, and comparable commercial coverage.</a:t>
+            </a:r>
+          </a:p>
+        </p:txBody>
+      </p:sp>
+      <p:sp>
+        <p:nvSpPr>
+          <p:cNvPr id="27" name="Rounded Rectangle 26"/>
+          <p:cNvSpPr/>
+          <p:nvPr/>
+        </p:nvSpPr>
+        <p:spPr>
+          <a:xfrm>
+            <a:off x="6126480" y="4078224"/>
+            <a:ext cx="5074920" cy="896112"/>
+          </a:xfrm>
+          <a:prstGeom prst="roundRect">
+            <a:avLst>
+              <a:gd name="adj" fmla="val 6000"/>
+            </a:avLst>
+          </a:prstGeom>
+          <a:solidFill>
+            <a:srgbClr val="F8FBFD"/>
+          </a:solidFill>
+          <a:ln>
+            <a:solidFill>
+              <a:srgbClr val="D9E2EC"/>
+            </a:solidFill>
+          </a:ln>
+        </p:spPr>
+        <p:style>
+          <a:lnRef idx="1">
+            <a:schemeClr val="accent1"/>
+          </a:lnRef>
+          <a:fillRef idx="3">
+            <a:schemeClr val="accent1"/>
+          </a:fillRef>
+          <a:effectRef idx="2">
+            <a:schemeClr val="accent1"/>
+          </a:effectRef>
+          <a:fontRef idx="minor">
+            <a:schemeClr val="lt1"/>
+          </a:fontRef>
+        </p:style>
+        <p:txBody>
+          <a:bodyPr rtlCol="0" anchor="ctr"/>
+          <a:lstStyle/>
+          <a:p>
+            <a:pPr algn="ctr"/>
+          </a:p>
+        </p:txBody>
+      </p:sp>
+      <p:sp>
+        <p:nvSpPr>
+          <p:cNvPr id="28" name="TextBox 27"/>
+          <p:cNvSpPr txBox="1"/>
+          <p:nvPr/>
+        </p:nvSpPr>
+        <p:spPr>
+          <a:xfrm>
+            <a:off x="6309360" y="4233672"/>
+            <a:ext cx="3383280" cy="164592"/>
+          </a:xfrm>
+          <a:prstGeom prst="rect">
+            <a:avLst/>
+          </a:prstGeom>
+          <a:noFill/>
+        </p:spPr>
+        <p:txBody>
+          <a:bodyPr wrap="square">
+            <a:spAutoFit/>
+          </a:bodyPr>
+          <a:lstStyle/>
+          <a:p>
+            <a:pPr algn="l">
+              <a:spcAft>
+                <a:spcPts val="0"/>
+              </a:spcAft>
+              <a:defRPr sz="1100" b="1">
+                <a:solidFill>
+                  <a:srgbClr val="102A43"/>
+                </a:solidFill>
+                <a:latin typeface="Aptos"/>
+              </a:defRPr>
+            </a:pPr>
+            <a:r>
+              <a:t>Improving Or Deteriorating Over Time</a:t>
+            </a:r>
+          </a:p>
+        </p:txBody>
+      </p:sp>
+      <p:sp>
+        <p:nvSpPr>
+          <p:cNvPr id="29" name="TextBox 28"/>
+          <p:cNvSpPr txBox="1"/>
+          <p:nvPr/>
+        </p:nvSpPr>
+        <p:spPr>
+          <a:xfrm>
+            <a:off x="9765792" y="4233672"/>
+            <a:ext cx="1188720" cy="164592"/>
+          </a:xfrm>
+          <a:prstGeom prst="rect">
+            <a:avLst/>
+          </a:prstGeom>
+          <a:noFill/>
+        </p:spPr>
+        <p:txBody>
+          <a:bodyPr wrap="square">
+            <a:spAutoFit/>
+          </a:bodyPr>
+          <a:lstStyle/>
+          <a:p>
+            <a:pPr algn="r">
+              <a:spcAft>
+                <a:spcPts val="0"/>
+              </a:spcAft>
+              <a:defRPr sz="1000" b="1">
+                <a:solidFill>
+                  <a:srgbClr val="B42318"/>
+                </a:solidFill>
+                <a:latin typeface="Aptos"/>
+              </a:defRPr>
+            </a:pPr>
+            <a:r>
+              <a:t>NOT READY</a:t>
+            </a:r>
+          </a:p>
+        </p:txBody>
+      </p:sp>
+      <p:sp>
+        <p:nvSpPr>
+          <p:cNvPr id="30" name="TextBox 29"/>
+          <p:cNvSpPr txBox="1"/>
+          <p:nvPr/>
+        </p:nvSpPr>
+        <p:spPr>
+          <a:xfrm>
+            <a:off x="6309360" y="4507992"/>
+            <a:ext cx="4617720" cy="274320"/>
+          </a:xfrm>
+          <a:prstGeom prst="rect">
+            <a:avLst/>
+          </a:prstGeom>
+          <a:noFill/>
+        </p:spPr>
+        <p:txBody>
+          <a:bodyPr wrap="square">
+            <a:spAutoFit/>
+          </a:bodyPr>
+          <a:lstStyle/>
+          <a:p>
+            <a:pPr algn="l">
+              <a:spcAft>
+                <a:spcPts val="0"/>
+              </a:spcAft>
+              <a:defRPr sz="800" b="0">
+                <a:solidFill>
+                  <a:srgbClr val="486581"/>
+                </a:solidFill>
+                <a:latin typeface="Aptos"/>
+              </a:defRPr>
+            </a:pPr>
+            <a:r>
+              <a:t>Requires 28 local days; currently mobility_days=2.</a:t>
+            </a:r>
+          </a:p>
+        </p:txBody>
+      </p:sp>
+      <p:sp>
+        <p:nvSpPr>
+          <p:cNvPr id="31" name="Rounded Rectangle 30"/>
+          <p:cNvSpPr/>
+          <p:nvPr/>
+        </p:nvSpPr>
+        <p:spPr>
+          <a:xfrm>
+            <a:off x="502920" y="5239512"/>
+            <a:ext cx="5074920" cy="896112"/>
+          </a:xfrm>
+          <a:prstGeom prst="roundRect">
+            <a:avLst>
+              <a:gd name="adj" fmla="val 6000"/>
+            </a:avLst>
+          </a:prstGeom>
+          <a:solidFill>
+            <a:srgbClr val="F8FBFD"/>
+          </a:solidFill>
+          <a:ln>
+            <a:solidFill>
+              <a:srgbClr val="D9E2EC"/>
+            </a:solidFill>
+          </a:ln>
+        </p:spPr>
+        <p:style>
+          <a:lnRef idx="1">
+            <a:schemeClr val="accent1"/>
+          </a:lnRef>
+          <a:fillRef idx="3">
+            <a:schemeClr val="accent1"/>
+          </a:fillRef>
+          <a:effectRef idx="2">
+            <a:schemeClr val="accent1"/>
+          </a:effectRef>
+          <a:fontRef idx="minor">
+            <a:schemeClr val="lt1"/>
+          </a:fontRef>
+        </p:style>
+        <p:txBody>
+          <a:bodyPr rtlCol="0" anchor="ctr"/>
+          <a:lstStyle/>
+          <a:p>
+            <a:pPr algn="ctr"/>
+          </a:p>
+        </p:txBody>
+      </p:sp>
+      <p:sp>
+        <p:nvSpPr>
+          <p:cNvPr id="32" name="TextBox 31"/>
+          <p:cNvSpPr txBox="1"/>
+          <p:nvPr/>
+        </p:nvSpPr>
+        <p:spPr>
+          <a:xfrm>
+            <a:off x="685800" y="5394960"/>
+            <a:ext cx="3383280" cy="164592"/>
+          </a:xfrm>
+          <a:prstGeom prst="rect">
+            <a:avLst/>
+          </a:prstGeom>
+          <a:noFill/>
+        </p:spPr>
+        <p:txBody>
+          <a:bodyPr wrap="square">
+            <a:spAutoFit/>
+          </a:bodyPr>
+          <a:lstStyle/>
+          <a:p>
+            <a:pPr algn="l">
+              <a:spcAft>
+                <a:spcPts val="0"/>
+              </a:spcAft>
+              <a:defRPr sz="1100" b="1">
+                <a:solidFill>
+                  <a:srgbClr val="102A43"/>
+                </a:solidFill>
+                <a:latin typeface="Aptos"/>
+              </a:defRPr>
+            </a:pPr>
+            <a:r>
+              <a:t>Defensible City Intelligence Score</a:t>
+            </a:r>
+          </a:p>
+        </p:txBody>
+      </p:sp>
+      <p:sp>
+        <p:nvSpPr>
+          <p:cNvPr id="33" name="TextBox 32"/>
+          <p:cNvSpPr txBox="1"/>
+          <p:nvPr/>
+        </p:nvSpPr>
+        <p:spPr>
+          <a:xfrm>
+            <a:off x="4142232" y="5394960"/>
+            <a:ext cx="1188720" cy="164592"/>
+          </a:xfrm>
+          <a:prstGeom prst="rect">
+            <a:avLst/>
+          </a:prstGeom>
+          <a:noFill/>
+        </p:spPr>
+        <p:txBody>
+          <a:bodyPr wrap="square">
+            <a:spAutoFit/>
+          </a:bodyPr>
+          <a:lstStyle/>
+          <a:p>
+            <a:pPr algn="r">
+              <a:spcAft>
+                <a:spcPts val="0"/>
+              </a:spcAft>
+              <a:defRPr sz="1000" b="1">
+                <a:solidFill>
+                  <a:srgbClr val="B42318"/>
+                </a:solidFill>
+                <a:latin typeface="Aptos"/>
+              </a:defRPr>
+            </a:pPr>
+            <a:r>
+              <a:t>NOT READY</a:t>
+            </a:r>
+          </a:p>
+        </p:txBody>
+      </p:sp>
+      <p:sp>
+        <p:nvSpPr>
+          <p:cNvPr id="34" name="TextBox 33"/>
+          <p:cNvSpPr txBox="1"/>
+          <p:nvPr/>
+        </p:nvSpPr>
+        <p:spPr>
+          <a:xfrm>
+            <a:off x="685800" y="5669280"/>
+            <a:ext cx="4617720" cy="274320"/>
+          </a:xfrm>
+          <a:prstGeom prst="rect">
+            <a:avLst/>
+          </a:prstGeom>
+          <a:noFill/>
+        </p:spPr>
+        <p:txBody>
+          <a:bodyPr wrap="square">
+            <a:spAutoFit/>
+          </a:bodyPr>
+          <a:lstStyle/>
+          <a:p>
+            <a:pPr algn="l">
+              <a:spcAft>
+                <a:spcPts val="0"/>
+              </a:spcAft>
+              <a:defRPr sz="800" b="0">
+                <a:solidFill>
+                  <a:srgbClr val="486581"/>
+                </a:solidFill>
+                <a:latin typeface="Aptos"/>
+              </a:defRPr>
+            </a:pPr>
+            <a:r>
+              <a:t>Requires approved commercial denominator, seven FX days, and 28 trend days; currently fx_days=2, mobility_days=2.</a:t>
+            </a:r>
+          </a:p>
+        </p:txBody>
+      </p:sp>
+    </p:spTree>
+  </p:cSld>
+  <p:clrMapOvr>
+    <a:masterClrMapping/>
+  </p:clrMapOvr>
+</p:sld>
+</file>
+
+<file path=ppt/slides/slide8.xml><?xml version="1.0" encoding="utf-8"?>
+<p:sld xmlns:a="http://schemas.openxmlformats.org/drawingml/2006/main" xmlns:p="http://schemas.openxmlformats.org/presentationml/2006/main" xmlns:r="http://schemas.openxmlformats.org/officeDocument/2006/relationships">
+  <p:cSld>
+    <p:bg>
+      <p:bgPr>
+        <a:solidFill>
+          <a:srgbClr val="FFFFFF"/>
+        </a:solidFill>
+        <a:effectLst/>
+      </p:bgPr>
+    </p:bg>
+    <p:spTree>
+      <p:nvGrpSpPr>
+        <p:cNvPr id="1" name=""/>
+        <p:cNvGrpSpPr/>
+        <p:nvPr/>
+      </p:nvGrpSpPr>
+      <p:grpSpPr/>
+      <p:sp>
+        <p:nvSpPr>
+          <p:cNvPr id="2" name="TextBox 1"/>
+          <p:cNvSpPr txBox="1"/>
+          <p:nvPr/>
+        </p:nvSpPr>
+        <p:spPr>
+          <a:xfrm>
+            <a:off x="502920" y="237744"/>
+            <a:ext cx="2011680" cy="228600"/>
+          </a:xfrm>
+          <a:prstGeom prst="rect">
+            <a:avLst/>
+          </a:prstGeom>
+          <a:noFill/>
+        </p:spPr>
+        <p:txBody>
+          <a:bodyPr wrap="square">
+            <a:spAutoFit/>
+          </a:bodyPr>
+          <a:lstStyle/>
+          <a:p>
+            <a:pPr algn="l">
+              <a:spcAft>
+                <a:spcPts val="0"/>
+              </a:spcAft>
+              <a:defRPr sz="1000" b="1">
+                <a:solidFill>
+                  <a:srgbClr val="0B6E99"/>
+                </a:solidFill>
+                <a:latin typeface="Aptos"/>
+              </a:defRPr>
+            </a:pPr>
+            <a:r>
+              <a:t>AFRICA PULSE</a:t>
+            </a:r>
+          </a:p>
+        </p:txBody>
+      </p:sp>
+      <p:sp>
+        <p:nvSpPr>
+          <p:cNvPr id="3" name="TextBox 2"/>
+          <p:cNvSpPr txBox="1"/>
+          <p:nvPr/>
+        </p:nvSpPr>
+        <p:spPr>
+          <a:xfrm>
+            <a:off x="502920" y="548640"/>
+            <a:ext cx="10972800" cy="411480"/>
+          </a:xfrm>
+          <a:prstGeom prst="rect">
+            <a:avLst/>
+          </a:prstGeom>
+          <a:noFill/>
+        </p:spPr>
+        <p:txBody>
+          <a:bodyPr wrap="square">
+            <a:spAutoFit/>
+          </a:bodyPr>
+          <a:lstStyle/>
+          <a:p>
+            <a:pPr algn="l">
+              <a:spcAft>
+                <a:spcPts val="0"/>
+              </a:spcAft>
+              <a:defRPr sz="2600" b="1">
+                <a:solidFill>
+                  <a:srgbClr val="102A43"/>
+                </a:solidFill>
+                <a:latin typeface="Aptos"/>
+              </a:defRPr>
+            </a:pPr>
+            <a:r>
+              <a:t>The next decision is operational maturity, not new features</a:t>
+            </a:r>
+          </a:p>
+        </p:txBody>
+      </p:sp>
+      <p:sp>
+        <p:nvSpPr>
+          <p:cNvPr id="4" name="TextBox 3"/>
+          <p:cNvSpPr txBox="1"/>
+          <p:nvPr/>
+        </p:nvSpPr>
+        <p:spPr>
+          <a:xfrm>
+            <a:off x="502920" y="1024128"/>
+            <a:ext cx="10972800" cy="237744"/>
+          </a:xfrm>
+          <a:prstGeom prst="rect">
+            <a:avLst/>
+          </a:prstGeom>
+          <a:noFill/>
+        </p:spPr>
+        <p:txBody>
+          <a:bodyPr wrap="square">
+            <a:spAutoFit/>
+          </a:bodyPr>
+          <a:lstStyle/>
+          <a:p>
+            <a:pPr algn="l">
+              <a:spcAft>
+                <a:spcPts val="0"/>
+              </a:spcAft>
+              <a:defRPr sz="1100" b="0">
+                <a:solidFill>
+                  <a:srgbClr val="486581"/>
+                </a:solidFill>
+                <a:latin typeface="Aptos"/>
+              </a:defRPr>
+            </a:pPr>
+            <a:r>
+              <a:t>The platform is demonstrable today; scheduled collection will turn the initial vertical slice into a historical decision asset.</a:t>
+            </a:r>
+          </a:p>
+        </p:txBody>
+      </p:sp>
+      <p:sp>
+        <p:nvSpPr>
+          <p:cNvPr id="5" name="Rectangle 4"/>
+          <p:cNvSpPr/>
+          <p:nvPr/>
+        </p:nvSpPr>
+        <p:spPr>
+          <a:xfrm>
+            <a:off x="502920" y="1408176"/>
+            <a:ext cx="11155680" cy="18288"/>
+          </a:xfrm>
+          <a:prstGeom prst="rect">
+            <a:avLst/>
+          </a:prstGeom>
+          <a:solidFill>
+            <a:srgbClr val="D9E2EC"/>
+          </a:solidFill>
+          <a:ln>
+            <a:noFill/>
+          </a:ln>
+        </p:spPr>
+        <p:style>
+          <a:lnRef idx="1">
+            <a:schemeClr val="accent1"/>
+          </a:lnRef>
+          <a:fillRef idx="3">
+            <a:schemeClr val="accent1"/>
+          </a:fillRef>
+          <a:effectRef idx="2">
+            <a:schemeClr val="accent1"/>
+          </a:effectRef>
+          <a:fontRef idx="minor">
+            <a:schemeClr val="lt1"/>
+          </a:fontRef>
+        </p:style>
+        <p:txBody>
+          <a:bodyPr rtlCol="0" anchor="ctr"/>
+          <a:lstStyle/>
+          <a:p>
+            <a:pPr algn="ctr"/>
+          </a:p>
+        </p:txBody>
+      </p:sp>
+      <p:sp>
+        <p:nvSpPr>
+          <p:cNvPr id="6" name="TextBox 5"/>
+          <p:cNvSpPr txBox="1"/>
+          <p:nvPr/>
+        </p:nvSpPr>
+        <p:spPr>
+          <a:xfrm>
+            <a:off x="11292840" y="6446520"/>
+            <a:ext cx="274320" cy="146304"/>
+          </a:xfrm>
+          <a:prstGeom prst="rect">
+            <a:avLst/>
+          </a:prstGeom>
+          <a:noFill/>
+        </p:spPr>
+        <p:txBody>
+          <a:bodyPr wrap="square">
+            <a:spAutoFit/>
+          </a:bodyPr>
+          <a:lstStyle/>
+          <a:p>
+            <a:pPr algn="r">
+              <a:spcAft>
+                <a:spcPts val="0"/>
+              </a:spcAft>
+              <a:defRPr sz="900" b="1">
+                <a:solidFill>
+                  <a:srgbClr val="486581"/>
+                </a:solidFill>
+                <a:latin typeface="Aptos"/>
+              </a:defRPr>
+            </a:pPr>
+            <a:r>
+              <a:t>08</a:t>
             </a:r>
           </a:p>
         </p:txBody>

</xml_diff>